<commit_message>
added github link into ppt
</commit_message>
<xml_diff>
--- a/report/Project Presentation elg 5255.pptx
+++ b/report/Project Presentation elg 5255.pptx
@@ -7103,30 +7103,6 @@
       </p:pic>
       <p:pic>
         <p:nvPicPr>
-          <p:cNvPr id="3" name="Image 1" descr="preencoded.png"/>
-          <p:cNvPicPr>
-            <a:picLocks noChangeAspect="1"/>
-          </p:cNvPicPr>
-          <p:nvPr/>
-        </p:nvPicPr>
-        <p:blipFill>
-          <a:blip r:embed="rId4"/>
-          <a:stretch>
-            <a:fillRect/>
-          </a:stretch>
-        </p:blipFill>
-        <p:spPr>
-          <a:xfrm>
-            <a:off x="1219200" y="3429000"/>
-            <a:ext cx="114300" cy="114300"/>
-          </a:xfrm>
-          <a:prstGeom prst="rect">
-            <a:avLst/>
-          </a:prstGeom>
-        </p:spPr>
-      </p:pic>
-      <p:pic>
-        <p:nvPicPr>
           <p:cNvPr id="4" name="Image 2" descr="preencoded.png"/>
           <p:cNvPicPr>
             <a:picLocks noChangeAspect="1"/>
@@ -7151,7 +7127,7 @@
       </p:pic>
       <p:pic>
         <p:nvPicPr>
-          <p:cNvPr id="5" name="Image 3" descr="preencoded.png"/>
+          <p:cNvPr id="6" name="Image 4" descr="preencoded.png"/>
           <p:cNvPicPr>
             <a:picLocks noChangeAspect="1"/>
           </p:cNvPicPr>
@@ -7165,55 +7141,7 @@
         </p:blipFill>
         <p:spPr>
           <a:xfrm>
-            <a:off x="6096000" y="3429000"/>
-            <a:ext cx="114300" cy="114300"/>
-          </a:xfrm>
-          <a:prstGeom prst="rect">
-            <a:avLst/>
-          </a:prstGeom>
-        </p:spPr>
-      </p:pic>
-      <p:pic>
-        <p:nvPicPr>
-          <p:cNvPr id="6" name="Image 4" descr="preencoded.png"/>
-          <p:cNvPicPr>
-            <a:picLocks noChangeAspect="1"/>
-          </p:cNvPicPr>
-          <p:nvPr/>
-        </p:nvPicPr>
-        <p:blipFill>
-          <a:blip r:embed="rId4"/>
-          <a:stretch>
-            <a:fillRect/>
-          </a:stretch>
-        </p:blipFill>
-        <p:spPr>
-          <a:xfrm>
             <a:off x="8534400" y="3429000"/>
-            <a:ext cx="114300" cy="114300"/>
-          </a:xfrm>
-          <a:prstGeom prst="rect">
-            <a:avLst/>
-          </a:prstGeom>
-        </p:spPr>
-      </p:pic>
-      <p:pic>
-        <p:nvPicPr>
-          <p:cNvPr id="7" name="Image 5" descr="preencoded.png"/>
-          <p:cNvPicPr>
-            <a:picLocks noChangeAspect="1"/>
-          </p:cNvPicPr>
-          <p:nvPr/>
-        </p:nvPicPr>
-        <p:blipFill>
-          <a:blip r:embed="rId4"/>
-          <a:stretch>
-            <a:fillRect/>
-          </a:stretch>
-        </p:blipFill>
-        <p:spPr>
-          <a:xfrm>
-            <a:off x="10972800" y="3429000"/>
             <a:ext cx="114300" cy="114300"/>
           </a:xfrm>
           <a:prstGeom prst="rect">
@@ -7862,7 +7790,7 @@
               <a:buNone/>
             </a:pPr>
             <a:r>
-              <a:rPr lang="en-US" sz="1200">
+              <a:rPr lang="en-US" sz="1200" dirty="0">
                 <a:solidFill>
                   <a:srgbClr val="E5E7EB"/>
                 </a:solidFill>
@@ -7870,18 +7798,91 @@
                 <a:ea typeface="Open Sans" pitchFamily="34" charset="-122"/>
                 <a:cs typeface="Open Sans" pitchFamily="34" charset="-120"/>
               </a:rPr>
-              <a:t>December 2, </a:t>
-            </a:r>
+              <a:t>December 2, 2025</a:t>
+            </a:r>
+            <a:endParaRPr lang="en-US" sz="1200" dirty="0"/>
+          </a:p>
+        </p:txBody>
+      </p:sp>
+      <p:sp>
+        <p:nvSpPr>
+          <p:cNvPr id="30" name="Text 7"/>
+          <p:cNvSpPr/>
+          <p:nvPr/>
+        </p:nvSpPr>
+        <p:spPr>
+          <a:xfrm>
+            <a:off x="7353300" y="3531840"/>
+            <a:ext cx="2663190" cy="304800"/>
+          </a:xfrm>
+          <a:prstGeom prst="rect">
+            <a:avLst/>
+          </a:prstGeom>
+          <a:noFill/>
+          <a:ln/>
+        </p:spPr>
+        <p:txBody>
+          <a:bodyPr vert="horz" wrap="square" lIns="0" tIns="0" rIns="0" bIns="0" rtlCol="0" anchor="t"/>
+          <a:lstStyle/>
+          <a:p>
+            <a:pPr marL="0" indent="0">
+              <a:lnSpc>
+                <a:spcPts val="2400"/>
+              </a:lnSpc>
+              <a:buNone/>
+            </a:pPr>
+            <a:r>
+              <a:rPr lang="en-US" sz="1800" b="1" dirty="0">
+                <a:solidFill>
+                  <a:srgbClr val="FFFFFF"/>
+                </a:solidFill>
+                <a:latin typeface="Montserrat" pitchFamily="34" charset="0"/>
+                <a:ea typeface="Montserrat" pitchFamily="34" charset="-122"/>
+                <a:cs typeface="Montserrat" pitchFamily="34" charset="-120"/>
+              </a:rPr>
+              <a:t>Project Repository</a:t>
+            </a:r>
+            <a:endParaRPr lang="en-US" sz="1800" dirty="0"/>
+          </a:p>
+        </p:txBody>
+      </p:sp>
+      <p:sp>
+        <p:nvSpPr>
+          <p:cNvPr id="31" name="Text 8"/>
+          <p:cNvSpPr/>
+          <p:nvPr/>
+        </p:nvSpPr>
+        <p:spPr>
+          <a:xfrm>
+            <a:off x="7353300" y="3836640"/>
+            <a:ext cx="2219325" cy="228600"/>
+          </a:xfrm>
+          <a:prstGeom prst="rect">
+            <a:avLst/>
+          </a:prstGeom>
+          <a:noFill/>
+          <a:ln/>
+        </p:spPr>
+        <p:txBody>
+          <a:bodyPr vert="horz" wrap="square" lIns="0" tIns="0" rIns="0" bIns="0" rtlCol="0" anchor="t"/>
+          <a:lstStyle/>
+          <a:p>
+            <a:pPr marL="0" indent="0">
+              <a:lnSpc>
+                <a:spcPts val="1800"/>
+              </a:lnSpc>
+              <a:buNone/>
+            </a:pPr>
             <a:r>
               <a:rPr lang="en-US" sz="1200" dirty="0">
                 <a:solidFill>
-                  <a:srgbClr val="E5E7EB"/>
+                  <a:srgbClr val="D1D5DB"/>
                 </a:solidFill>
                 <a:latin typeface="Open Sans" pitchFamily="34" charset="0"/>
                 <a:ea typeface="Open Sans" pitchFamily="34" charset="-122"/>
                 <a:cs typeface="Open Sans" pitchFamily="34" charset="-120"/>
               </a:rPr>
-              <a:t>2025</a:t>
+              <a:t>GitHub</a:t>
             </a:r>
             <a:endParaRPr lang="en-US" sz="1200" dirty="0"/>
           </a:p>
@@ -7889,125 +7890,40 @@
       </p:sp>
       <p:sp>
         <p:nvSpPr>
-          <p:cNvPr id="30" name="Text 7"/>
-          <p:cNvSpPr/>
-          <p:nvPr/>
-        </p:nvSpPr>
-        <p:spPr>
-          <a:xfrm>
-            <a:off x="7353300" y="3531840"/>
-            <a:ext cx="2663190" cy="304800"/>
-          </a:xfrm>
-          <a:prstGeom prst="rect">
-            <a:avLst/>
-          </a:prstGeom>
-          <a:noFill/>
-          <a:ln/>
-        </p:spPr>
-        <p:txBody>
-          <a:bodyPr vert="horz" wrap="square" lIns="0" tIns="0" rIns="0" bIns="0" rtlCol="0" anchor="t"/>
-          <a:lstStyle/>
-          <a:p>
-            <a:pPr marL="0" indent="0">
-              <a:lnSpc>
-                <a:spcPts val="2400"/>
-              </a:lnSpc>
-              <a:buNone/>
-            </a:pPr>
-            <a:r>
-              <a:rPr lang="en-US" sz="1800" b="1" dirty="0">
-                <a:solidFill>
-                  <a:srgbClr val="FFFFFF"/>
-                </a:solidFill>
-                <a:latin typeface="Montserrat" pitchFamily="34" charset="0"/>
-                <a:ea typeface="Montserrat" pitchFamily="34" charset="-122"/>
-                <a:cs typeface="Montserrat" pitchFamily="34" charset="-120"/>
-              </a:rPr>
-              <a:t>Project Repository</a:t>
-            </a:r>
-            <a:endParaRPr lang="en-US" sz="1800" dirty="0"/>
-          </a:p>
-        </p:txBody>
-      </p:sp>
-      <p:sp>
-        <p:nvSpPr>
-          <p:cNvPr id="31" name="Text 8"/>
-          <p:cNvSpPr/>
-          <p:nvPr/>
-        </p:nvSpPr>
-        <p:spPr>
-          <a:xfrm>
-            <a:off x="7353300" y="3836640"/>
-            <a:ext cx="2219325" cy="228600"/>
-          </a:xfrm>
-          <a:prstGeom prst="rect">
-            <a:avLst/>
-          </a:prstGeom>
-          <a:noFill/>
-          <a:ln/>
-        </p:spPr>
-        <p:txBody>
-          <a:bodyPr vert="horz" wrap="square" lIns="0" tIns="0" rIns="0" bIns="0" rtlCol="0" anchor="t"/>
-          <a:lstStyle/>
-          <a:p>
-            <a:pPr marL="0" indent="0">
+          <p:cNvPr id="32" name="Text 9"/>
+          <p:cNvSpPr/>
+          <p:nvPr/>
+        </p:nvSpPr>
+        <p:spPr>
+          <a:xfrm>
+            <a:off x="7019925" y="4331940"/>
+            <a:ext cx="2809875" cy="201960"/>
+          </a:xfrm>
+          <a:prstGeom prst="rect">
+            <a:avLst/>
+          </a:prstGeom>
+          <a:noFill/>
+          <a:ln/>
+        </p:spPr>
+        <p:txBody>
+          <a:bodyPr vert="horz" wrap="square" lIns="0" tIns="0" rIns="0" bIns="0" rtlCol="0" anchor="t"/>
+          <a:lstStyle/>
+          <a:p>
+            <a:pPr>
               <a:lnSpc>
                 <a:spcPts val="1800"/>
               </a:lnSpc>
-              <a:buNone/>
             </a:pPr>
             <a:r>
               <a:rPr lang="en-US" sz="1200" dirty="0">
                 <a:solidFill>
-                  <a:srgbClr val="D1D5DB"/>
+                  <a:srgbClr val="E5E7EB"/>
                 </a:solidFill>
                 <a:latin typeface="Open Sans" pitchFamily="34" charset="0"/>
                 <a:ea typeface="Open Sans" pitchFamily="34" charset="-122"/>
                 <a:cs typeface="Open Sans" pitchFamily="34" charset="-120"/>
               </a:rPr>
-              <a:t>GitHub</a:t>
-            </a:r>
-            <a:endParaRPr lang="en-US" sz="1200" dirty="0"/>
-          </a:p>
-        </p:txBody>
-      </p:sp>
-      <p:sp>
-        <p:nvSpPr>
-          <p:cNvPr id="32" name="Text 9"/>
-          <p:cNvSpPr/>
-          <p:nvPr/>
-        </p:nvSpPr>
-        <p:spPr>
-          <a:xfrm>
-            <a:off x="7019925" y="4331940"/>
-            <a:ext cx="4869180" cy="228600"/>
-          </a:xfrm>
-          <a:prstGeom prst="rect">
-            <a:avLst/>
-          </a:prstGeom>
-          <a:noFill/>
-          <a:ln/>
-        </p:spPr>
-        <p:txBody>
-          <a:bodyPr vert="horz" wrap="square" lIns="0" tIns="0" rIns="0" bIns="0" rtlCol="0" anchor="t"/>
-          <a:lstStyle/>
-          <a:p>
-            <a:pPr marL="0" indent="0">
-              <a:lnSpc>
-                <a:spcPts val="1800"/>
-              </a:lnSpc>
-              <a:buNone/>
-            </a:pPr>
-            <a:r>
-              <a:rPr lang="en-US" sz="1200" dirty="0">
-                <a:solidFill>
-                  <a:srgbClr val="E5E7EB"/>
-                </a:solidFill>
-                <a:latin typeface="Open Sans" pitchFamily="34" charset="0"/>
-                <a:ea typeface="Open Sans" pitchFamily="34" charset="-122"/>
-                <a:cs typeface="Open Sans" pitchFamily="34" charset="-120"/>
-              </a:rPr>
-              <a:t>https://github.com/mohammad1774/applied_ml_project</a:t>
+              <a:t>https://github.com/mohammad1774/applied_ml_project#</a:t>
             </a:r>
             <a:endParaRPr lang="en-US" sz="1200" dirty="0"/>
           </a:p>

</xml_diff>

<commit_message>
Final Commit for project submission
</commit_message>
<xml_diff>
--- a/report/Project Presentation elg 5255.pptx
+++ b/report/Project Presentation elg 5255.pptx
@@ -5,7 +5,7 @@
     <p:sldMasterId id="2147483648" r:id="rId1"/>
   </p:sldMasterIdLst>
   <p:notesMasterIdLst>
-    <p:notesMasterId r:id="rId16"/>
+    <p:notesMasterId r:id="rId17"/>
   </p:notesMasterIdLst>
   <p:sldIdLst>
     <p:sldId id="256" r:id="rId2"/>
@@ -22,6 +22,7 @@
     <p:sldId id="266" r:id="rId13"/>
     <p:sldId id="267" r:id="rId14"/>
     <p:sldId id="268" r:id="rId15"/>
+    <p:sldId id="270" r:id="rId16"/>
   </p:sldIdLst>
   <p:sldSz cx="12192000" cy="6858000"/>
   <p:notesSz cx="6858000" cy="12192000"/>
@@ -1949,7 +1950,7 @@
         </p:nvSpPr>
         <p:spPr>
           <a:xfrm>
-            <a:off x="5672138" y="4324350"/>
+            <a:off x="5713095" y="4132847"/>
             <a:ext cx="1337310" cy="266700"/>
           </a:xfrm>
           <a:prstGeom prst="rect">
@@ -1979,30 +1980,7 @@
               </a:rPr>
               <a:t>Mohammad</a:t>
             </a:r>
-            <a:endParaRPr lang="en-US" sz="1500" dirty="0"/>
-          </a:p>
-        </p:txBody>
-      </p:sp>
-      <p:sp>
-        <p:nvSpPr>
-          <p:cNvPr id="12" name="Text 4"/>
-          <p:cNvSpPr/>
-          <p:nvPr/>
-        </p:nvSpPr>
-        <p:spPr>
-          <a:xfrm>
-            <a:off x="4291013" y="4667250"/>
-            <a:ext cx="4331970" cy="266700"/>
-          </a:xfrm>
-          <a:prstGeom prst="rect">
-            <a:avLst/>
-          </a:prstGeom>
-          <a:noFill/>
-          <a:ln/>
-        </p:spPr>
-        <p:txBody>
-          <a:bodyPr vert="horz" wrap="square" lIns="0" tIns="0" rIns="0" bIns="0" rtlCol="0" anchor="t"/>
-          <a:lstStyle/>
+          </a:p>
           <a:p>
             <a:pPr marL="0" indent="0">
               <a:lnSpc>
@@ -2011,49 +1989,73 @@
               <a:buNone/>
             </a:pPr>
             <a:r>
-              <a:rPr lang="en-US" sz="1350" dirty="0">
-                <a:solidFill>
-                  <a:srgbClr val="D1D5DB"/>
+              <a:rPr lang="en-US" sz="1500" b="1" dirty="0">
+                <a:solidFill>
+                  <a:srgbClr val="FFFFFF"/>
                 </a:solidFill>
                 <a:latin typeface="Open Sans" pitchFamily="34" charset="0"/>
                 <a:ea typeface="Open Sans" pitchFamily="34" charset="-122"/>
                 <a:cs typeface="Open Sans" pitchFamily="34" charset="-120"/>
               </a:rPr>
-              <a:t>Master's of Engineering, University of Ottawa</a:t>
-            </a:r>
-            <a:endParaRPr lang="en-US" sz="1350" dirty="0"/>
-          </a:p>
-        </p:txBody>
-      </p:sp>
-      <p:sp>
-        <p:nvSpPr>
-          <p:cNvPr id="13" name="Text 5"/>
-          <p:cNvSpPr/>
-          <p:nvPr/>
-        </p:nvSpPr>
-        <p:spPr>
-          <a:xfrm>
-            <a:off x="5624513" y="5086350"/>
-            <a:ext cx="1383030" cy="190500"/>
-          </a:xfrm>
-          <a:prstGeom prst="rect">
-            <a:avLst/>
-          </a:prstGeom>
-          <a:noFill/>
-          <a:ln/>
-        </p:spPr>
-        <p:txBody>
-          <a:bodyPr vert="horz" wrap="square" lIns="0" tIns="0" rIns="0" bIns="0" rtlCol="0" anchor="t"/>
-          <a:lstStyle/>
+              <a:t>#300480272</a:t>
+            </a:r>
+          </a:p>
           <a:p>
             <a:pPr marL="0" indent="0">
               <a:lnSpc>
-                <a:spcPts val="1500"/>
-              </a:lnSpc>
-              <a:buNone/>
-            </a:pPr>
-            <a:r>
-              <a:rPr lang="en-US" sz="1050" dirty="0">
+                <a:spcPts val="2100"/>
+              </a:lnSpc>
+              <a:buNone/>
+            </a:pPr>
+            <a:endParaRPr lang="en-US" sz="1500" b="1" dirty="0">
+              <a:solidFill>
+                <a:srgbClr val="FFFFFF"/>
+              </a:solidFill>
+              <a:latin typeface="Open Sans" pitchFamily="34" charset="0"/>
+              <a:ea typeface="Open Sans" pitchFamily="34" charset="-122"/>
+              <a:cs typeface="Open Sans" pitchFamily="34" charset="-120"/>
+            </a:endParaRPr>
+          </a:p>
+          <a:p>
+            <a:pPr marL="0" indent="0">
+              <a:lnSpc>
+                <a:spcPts val="2100"/>
+              </a:lnSpc>
+              <a:buNone/>
+            </a:pPr>
+            <a:endParaRPr lang="en-US" sz="1500" dirty="0"/>
+          </a:p>
+        </p:txBody>
+      </p:sp>
+      <p:sp>
+        <p:nvSpPr>
+          <p:cNvPr id="12" name="Text 4"/>
+          <p:cNvSpPr/>
+          <p:nvPr/>
+        </p:nvSpPr>
+        <p:spPr>
+          <a:xfrm>
+            <a:off x="4291013" y="4667250"/>
+            <a:ext cx="4331970" cy="266700"/>
+          </a:xfrm>
+          <a:prstGeom prst="rect">
+            <a:avLst/>
+          </a:prstGeom>
+          <a:noFill/>
+          <a:ln/>
+        </p:spPr>
+        <p:txBody>
+          <a:bodyPr vert="horz" wrap="square" lIns="0" tIns="0" rIns="0" bIns="0" rtlCol="0" anchor="t"/>
+          <a:lstStyle/>
+          <a:p>
+            <a:pPr marL="0" indent="0">
+              <a:lnSpc>
+                <a:spcPts val="2100"/>
+              </a:lnSpc>
+              <a:buNone/>
+            </a:pPr>
+            <a:r>
+              <a:rPr lang="en-US" sz="1350" dirty="0">
                 <a:solidFill>
                   <a:srgbClr val="D1D5DB"/>
                 </a:solidFill>
@@ -2061,7 +2063,49 @@
                 <a:ea typeface="Open Sans" pitchFamily="34" charset="-122"/>
                 <a:cs typeface="Open Sans" pitchFamily="34" charset="-120"/>
               </a:rPr>
-              <a:t>December 1, 2025</a:t>
+              <a:t>Master's of Engineering, University of Ottawa</a:t>
+            </a:r>
+            <a:endParaRPr lang="en-US" sz="1350" dirty="0"/>
+          </a:p>
+        </p:txBody>
+      </p:sp>
+      <p:sp>
+        <p:nvSpPr>
+          <p:cNvPr id="13" name="Text 5"/>
+          <p:cNvSpPr/>
+          <p:nvPr/>
+        </p:nvSpPr>
+        <p:spPr>
+          <a:xfrm>
+            <a:off x="5624513" y="5086350"/>
+            <a:ext cx="1383030" cy="190500"/>
+          </a:xfrm>
+          <a:prstGeom prst="rect">
+            <a:avLst/>
+          </a:prstGeom>
+          <a:noFill/>
+          <a:ln/>
+        </p:spPr>
+        <p:txBody>
+          <a:bodyPr vert="horz" wrap="square" lIns="0" tIns="0" rIns="0" bIns="0" rtlCol="0" anchor="t"/>
+          <a:lstStyle/>
+          <a:p>
+            <a:pPr marL="0" indent="0">
+              <a:lnSpc>
+                <a:spcPts val="1500"/>
+              </a:lnSpc>
+              <a:buNone/>
+            </a:pPr>
+            <a:r>
+              <a:rPr lang="en-US" sz="1050" dirty="0">
+                <a:solidFill>
+                  <a:srgbClr val="D1D5DB"/>
+                </a:solidFill>
+                <a:latin typeface="Open Sans" pitchFamily="34" charset="0"/>
+                <a:ea typeface="Open Sans" pitchFamily="34" charset="-122"/>
+                <a:cs typeface="Open Sans" pitchFamily="34" charset="-120"/>
+              </a:rPr>
+              <a:t>December 2, 2025</a:t>
             </a:r>
             <a:endParaRPr lang="en-US" sz="1050" dirty="0"/>
           </a:p>
@@ -4564,6 +4608,36 @@
           </a:prstGeom>
         </p:spPr>
       </p:pic>
+      <p:pic>
+        <p:nvPicPr>
+          <p:cNvPr id="39" name="Picture 38" descr="A graph of different colored bars&#10;&#10;AI-generated content may be incorrect.">
+            <a:extLst>
+              <a:ext uri="{FF2B5EF4-FFF2-40B4-BE49-F238E27FC236}">
+                <a16:creationId xmlns:a16="http://schemas.microsoft.com/office/drawing/2014/main" id="{B87E095F-4208-E1B5-5111-9C1C17356BBD}"/>
+              </a:ext>
+            </a:extLst>
+          </p:cNvPr>
+          <p:cNvPicPr>
+            <a:picLocks noChangeAspect="1"/>
+          </p:cNvPicPr>
+          <p:nvPr/>
+        </p:nvPicPr>
+        <p:blipFill>
+          <a:blip r:embed="rId19"/>
+          <a:stretch>
+            <a:fillRect/>
+          </a:stretch>
+        </p:blipFill>
+        <p:spPr>
+          <a:xfrm>
+            <a:off x="1050112" y="4337223"/>
+            <a:ext cx="6284138" cy="2133600"/>
+          </a:xfrm>
+          <a:prstGeom prst="rect">
+            <a:avLst/>
+          </a:prstGeom>
+        </p:spPr>
+      </p:pic>
     </p:spTree>
   </p:cSld>
   <p:clrMapOvr>
@@ -8021,6 +8095,642 @@
 </p:sld>
 </file>
 
+<file path=ppt/slides/slide15.xml><?xml version="1.0" encoding="utf-8"?>
+<p:sld xmlns:a="http://schemas.openxmlformats.org/drawingml/2006/main" xmlns:r="http://schemas.openxmlformats.org/officeDocument/2006/relationships" xmlns:p="http://schemas.openxmlformats.org/presentationml/2006/main">
+  <p:cSld>
+    <p:spTree>
+      <p:nvGrpSpPr>
+        <p:cNvPr id="1" name="">
+          <a:extLst>
+            <a:ext uri="{FF2B5EF4-FFF2-40B4-BE49-F238E27FC236}">
+              <a16:creationId xmlns:a16="http://schemas.microsoft.com/office/drawing/2014/main" id="{B680D884-6149-50D5-FCA4-1B66D33030FC}"/>
+            </a:ext>
+          </a:extLst>
+        </p:cNvPr>
+        <p:cNvGrpSpPr/>
+        <p:nvPr/>
+      </p:nvGrpSpPr>
+      <p:grpSpPr>
+        <a:xfrm>
+          <a:off x="0" y="0"/>
+          <a:ext cx="0" cy="0"/>
+          <a:chOff x="0" y="0"/>
+          <a:chExt cx="0" cy="0"/>
+        </a:xfrm>
+      </p:grpSpPr>
+      <p:pic>
+        <p:nvPicPr>
+          <p:cNvPr id="2" name="Image 0" descr="preencoded.png">
+            <a:extLst>
+              <a:ext uri="{FF2B5EF4-FFF2-40B4-BE49-F238E27FC236}">
+                <a16:creationId xmlns:a16="http://schemas.microsoft.com/office/drawing/2014/main" id="{53255975-5951-A1D7-E011-56B9BDDAC9C0}"/>
+              </a:ext>
+            </a:extLst>
+          </p:cNvPr>
+          <p:cNvPicPr>
+            <a:picLocks noChangeAspect="1"/>
+          </p:cNvPicPr>
+          <p:nvPr/>
+        </p:nvPicPr>
+        <p:blipFill>
+          <a:blip r:embed="rId2"/>
+          <a:stretch>
+            <a:fillRect/>
+          </a:stretch>
+        </p:blipFill>
+        <p:spPr>
+          <a:xfrm>
+            <a:off x="0" y="-423"/>
+            <a:ext cx="12192000" cy="6858000"/>
+          </a:xfrm>
+          <a:prstGeom prst="rect">
+            <a:avLst/>
+          </a:prstGeom>
+        </p:spPr>
+      </p:pic>
+      <p:pic>
+        <p:nvPicPr>
+          <p:cNvPr id="3" name="Image 1" descr="preencoded.png">
+            <a:extLst>
+              <a:ext uri="{FF2B5EF4-FFF2-40B4-BE49-F238E27FC236}">
+                <a16:creationId xmlns:a16="http://schemas.microsoft.com/office/drawing/2014/main" id="{4A31785D-CA3E-10F9-52CC-162B53E22271}"/>
+              </a:ext>
+            </a:extLst>
+          </p:cNvPr>
+          <p:cNvPicPr>
+            <a:picLocks noChangeAspect="1"/>
+          </p:cNvPicPr>
+          <p:nvPr/>
+        </p:nvPicPr>
+        <p:blipFill>
+          <a:blip r:embed="rId3"/>
+          <a:stretch>
+            <a:fillRect/>
+          </a:stretch>
+        </p:blipFill>
+        <p:spPr>
+          <a:xfrm>
+            <a:off x="0" y="5143500"/>
+            <a:ext cx="12192000" cy="1714500"/>
+          </a:xfrm>
+          <a:prstGeom prst="rect">
+            <a:avLst/>
+          </a:prstGeom>
+        </p:spPr>
+      </p:pic>
+      <p:sp>
+        <p:nvSpPr>
+          <p:cNvPr id="8" name="Text 21">
+            <a:extLst>
+              <a:ext uri="{FF2B5EF4-FFF2-40B4-BE49-F238E27FC236}">
+                <a16:creationId xmlns:a16="http://schemas.microsoft.com/office/drawing/2014/main" id="{073BE7F7-8816-8F1B-9729-304E8D3E5A15}"/>
+              </a:ext>
+            </a:extLst>
+          </p:cNvPr>
+          <p:cNvSpPr/>
+          <p:nvPr/>
+        </p:nvSpPr>
+        <p:spPr>
+          <a:xfrm>
+            <a:off x="4413616" y="3145483"/>
+            <a:ext cx="3378250" cy="381000"/>
+          </a:xfrm>
+          <a:prstGeom prst="rect">
+            <a:avLst/>
+          </a:prstGeom>
+          <a:noFill/>
+          <a:ln/>
+        </p:spPr>
+        <p:txBody>
+          <a:bodyPr vert="horz" wrap="square" lIns="0" tIns="0" rIns="0" bIns="0" rtlCol="0" anchor="t"/>
+          <a:lstStyle/>
+          <a:p>
+            <a:pPr marL="0" indent="0" algn="ctr">
+              <a:lnSpc>
+                <a:spcPts val="1500"/>
+              </a:lnSpc>
+              <a:buNone/>
+            </a:pPr>
+            <a:r>
+              <a:rPr lang="en-US" sz="1050" dirty="0">
+                <a:solidFill>
+                  <a:srgbClr val="D1D5DB"/>
+                </a:solidFill>
+                <a:latin typeface="Open Sans" pitchFamily="34" charset="0"/>
+                <a:ea typeface="Open Sans" pitchFamily="34" charset="-122"/>
+                <a:cs typeface="Open Sans" pitchFamily="34" charset="-120"/>
+              </a:rPr>
+              <a:t>Figure: TF-IDF Vectorizer Workflow for different Models</a:t>
+            </a:r>
+            <a:endParaRPr lang="en-US" sz="1050" dirty="0"/>
+          </a:p>
+        </p:txBody>
+      </p:sp>
+      <p:pic>
+        <p:nvPicPr>
+          <p:cNvPr id="9" name="Image 2" descr="preencoded.png">
+            <a:extLst>
+              <a:ext uri="{FF2B5EF4-FFF2-40B4-BE49-F238E27FC236}">
+                <a16:creationId xmlns:a16="http://schemas.microsoft.com/office/drawing/2014/main" id="{5BD92048-286C-D650-50ED-BD7FFB486A40}"/>
+              </a:ext>
+            </a:extLst>
+          </p:cNvPr>
+          <p:cNvPicPr>
+            <a:picLocks noChangeAspect="1"/>
+          </p:cNvPicPr>
+          <p:nvPr/>
+        </p:nvPicPr>
+        <p:blipFill>
+          <a:blip r:embed="rId4"/>
+          <a:stretch>
+            <a:fillRect/>
+          </a:stretch>
+        </p:blipFill>
+        <p:spPr>
+          <a:xfrm>
+            <a:off x="8137698" y="4465"/>
+            <a:ext cx="4063901" cy="2286000"/>
+          </a:xfrm>
+          <a:prstGeom prst="rect">
+            <a:avLst/>
+          </a:prstGeom>
+        </p:spPr>
+      </p:pic>
+      <p:pic>
+        <p:nvPicPr>
+          <p:cNvPr id="10" name="Image 28" descr="preencoded.png">
+            <a:extLst>
+              <a:ext uri="{FF2B5EF4-FFF2-40B4-BE49-F238E27FC236}">
+                <a16:creationId xmlns:a16="http://schemas.microsoft.com/office/drawing/2014/main" id="{F1E504B5-2F2B-7627-3F76-4DCEB44BCE49}"/>
+              </a:ext>
+            </a:extLst>
+          </p:cNvPr>
+          <p:cNvPicPr>
+            <a:picLocks noChangeAspect="1"/>
+          </p:cNvPicPr>
+          <p:nvPr/>
+        </p:nvPicPr>
+        <p:blipFill>
+          <a:blip r:embed="rId5"/>
+          <a:stretch>
+            <a:fillRect/>
+          </a:stretch>
+        </p:blipFill>
+        <p:spPr>
+          <a:xfrm>
+            <a:off x="303895" y="351986"/>
+            <a:ext cx="3606850" cy="3212287"/>
+          </a:xfrm>
+          <a:prstGeom prst="rect">
+            <a:avLst/>
+          </a:prstGeom>
+        </p:spPr>
+      </p:pic>
+      <p:sp>
+        <p:nvSpPr>
+          <p:cNvPr id="11" name="Text 21">
+            <a:extLst>
+              <a:ext uri="{FF2B5EF4-FFF2-40B4-BE49-F238E27FC236}">
+                <a16:creationId xmlns:a16="http://schemas.microsoft.com/office/drawing/2014/main" id="{4E60267D-68A2-15AD-58BB-87253BFF5B44}"/>
+              </a:ext>
+            </a:extLst>
+          </p:cNvPr>
+          <p:cNvSpPr/>
+          <p:nvPr/>
+        </p:nvSpPr>
+        <p:spPr>
+          <a:xfrm>
+            <a:off x="467566" y="3170732"/>
+            <a:ext cx="3378250" cy="381000"/>
+          </a:xfrm>
+          <a:prstGeom prst="rect">
+            <a:avLst/>
+          </a:prstGeom>
+          <a:noFill/>
+          <a:ln/>
+        </p:spPr>
+        <p:txBody>
+          <a:bodyPr vert="horz" wrap="square" lIns="0" tIns="0" rIns="0" bIns="0" rtlCol="0" anchor="t"/>
+          <a:lstStyle/>
+          <a:p>
+            <a:pPr marL="0" indent="0" algn="ctr">
+              <a:lnSpc>
+                <a:spcPts val="1500"/>
+              </a:lnSpc>
+              <a:buNone/>
+            </a:pPr>
+            <a:r>
+              <a:rPr lang="en-US" sz="1050" dirty="0">
+                <a:solidFill>
+                  <a:srgbClr val="D1D5DB"/>
+                </a:solidFill>
+                <a:latin typeface="Open Sans" pitchFamily="34" charset="0"/>
+                <a:ea typeface="Open Sans" pitchFamily="34" charset="-122"/>
+                <a:cs typeface="Open Sans" pitchFamily="34" charset="-120"/>
+              </a:rPr>
+              <a:t>Figure: Bag of Words Vectorizer Workflow for different  Models</a:t>
+            </a:r>
+            <a:endParaRPr lang="en-US" sz="1050" dirty="0"/>
+          </a:p>
+        </p:txBody>
+      </p:sp>
+      <p:pic>
+        <p:nvPicPr>
+          <p:cNvPr id="18" name="Image 27" descr="preencoded.png">
+            <a:extLst>
+              <a:ext uri="{FF2B5EF4-FFF2-40B4-BE49-F238E27FC236}">
+                <a16:creationId xmlns:a16="http://schemas.microsoft.com/office/drawing/2014/main" id="{B8F6D283-DE66-5964-0426-6C5A788EC459}"/>
+              </a:ext>
+            </a:extLst>
+          </p:cNvPr>
+          <p:cNvPicPr>
+            <a:picLocks noChangeAspect="1"/>
+          </p:cNvPicPr>
+          <p:nvPr/>
+        </p:nvPicPr>
+        <p:blipFill>
+          <a:blip r:embed="rId6"/>
+          <a:stretch>
+            <a:fillRect/>
+          </a:stretch>
+        </p:blipFill>
+        <p:spPr>
+          <a:xfrm>
+            <a:off x="4963672" y="85286"/>
+            <a:ext cx="257175" cy="228600"/>
+          </a:xfrm>
+          <a:prstGeom prst="rect">
+            <a:avLst/>
+          </a:prstGeom>
+        </p:spPr>
+      </p:pic>
+      <p:sp>
+        <p:nvSpPr>
+          <p:cNvPr id="19" name="Text 20">
+            <a:extLst>
+              <a:ext uri="{FF2B5EF4-FFF2-40B4-BE49-F238E27FC236}">
+                <a16:creationId xmlns:a16="http://schemas.microsoft.com/office/drawing/2014/main" id="{5FCBB032-ADBF-FD32-5F7E-50CF4EFF7495}"/>
+              </a:ext>
+            </a:extLst>
+          </p:cNvPr>
+          <p:cNvSpPr/>
+          <p:nvPr/>
+        </p:nvSpPr>
+        <p:spPr>
+          <a:xfrm>
+            <a:off x="5335147" y="47186"/>
+            <a:ext cx="3606850" cy="304800"/>
+          </a:xfrm>
+          <a:prstGeom prst="rect">
+            <a:avLst/>
+          </a:prstGeom>
+          <a:noFill/>
+          <a:ln/>
+        </p:spPr>
+        <p:txBody>
+          <a:bodyPr vert="horz" wrap="square" lIns="0" tIns="0" rIns="0" bIns="0" rtlCol="0" anchor="t"/>
+          <a:lstStyle/>
+          <a:p>
+            <a:pPr marL="0" indent="0">
+              <a:lnSpc>
+                <a:spcPts val="2400"/>
+              </a:lnSpc>
+              <a:buNone/>
+            </a:pPr>
+            <a:r>
+              <a:rPr lang="en-US" sz="1800" dirty="0">
+                <a:solidFill>
+                  <a:srgbClr val="FFFFFF"/>
+                </a:solidFill>
+                <a:latin typeface="Montserrat" pitchFamily="34" charset="0"/>
+                <a:ea typeface="Montserrat" pitchFamily="34" charset="-122"/>
+                <a:cs typeface="Montserrat" pitchFamily="34" charset="-120"/>
+              </a:rPr>
+              <a:t>Workflow</a:t>
+            </a:r>
+            <a:endParaRPr lang="en-US" sz="1800" dirty="0"/>
+          </a:p>
+        </p:txBody>
+      </p:sp>
+      <p:pic>
+        <p:nvPicPr>
+          <p:cNvPr id="22" name="Picture 21" descr="A diagram of a model&#10;&#10;AI-generated content may be incorrect.">
+            <a:extLst>
+              <a:ext uri="{FF2B5EF4-FFF2-40B4-BE49-F238E27FC236}">
+                <a16:creationId xmlns:a16="http://schemas.microsoft.com/office/drawing/2014/main" id="{68DEFD54-1E71-4E9A-6588-42F33B90DED1}"/>
+              </a:ext>
+            </a:extLst>
+          </p:cNvPr>
+          <p:cNvPicPr>
+            <a:picLocks noChangeAspect="1"/>
+          </p:cNvPicPr>
+          <p:nvPr/>
+        </p:nvPicPr>
+        <p:blipFill>
+          <a:blip r:embed="rId7"/>
+          <a:stretch>
+            <a:fillRect/>
+          </a:stretch>
+        </p:blipFill>
+        <p:spPr>
+          <a:xfrm>
+            <a:off x="418195" y="432718"/>
+            <a:ext cx="3378250" cy="2707450"/>
+          </a:xfrm>
+          <a:prstGeom prst="rect">
+            <a:avLst/>
+          </a:prstGeom>
+        </p:spPr>
+      </p:pic>
+      <p:pic>
+        <p:nvPicPr>
+          <p:cNvPr id="24" name="Picture 23" descr="A diagram of a model&#10;&#10;AI-generated content may be incorrect.">
+            <a:extLst>
+              <a:ext uri="{FF2B5EF4-FFF2-40B4-BE49-F238E27FC236}">
+                <a16:creationId xmlns:a16="http://schemas.microsoft.com/office/drawing/2014/main" id="{08422368-4DFA-9DB0-2D3B-971BC1BACAB3}"/>
+              </a:ext>
+            </a:extLst>
+          </p:cNvPr>
+          <p:cNvPicPr>
+            <a:picLocks noChangeAspect="1"/>
+          </p:cNvPicPr>
+          <p:nvPr/>
+        </p:nvPicPr>
+        <p:blipFill>
+          <a:blip r:embed="rId8"/>
+          <a:stretch>
+            <a:fillRect/>
+          </a:stretch>
+        </p:blipFill>
+        <p:spPr>
+          <a:xfrm>
+            <a:off x="4398058" y="432718"/>
+            <a:ext cx="3393808" cy="2707450"/>
+          </a:xfrm>
+          <a:prstGeom prst="rect">
+            <a:avLst/>
+          </a:prstGeom>
+        </p:spPr>
+      </p:pic>
+      <p:pic>
+        <p:nvPicPr>
+          <p:cNvPr id="4" name="Image 28" descr="preencoded.png">
+            <a:extLst>
+              <a:ext uri="{FF2B5EF4-FFF2-40B4-BE49-F238E27FC236}">
+                <a16:creationId xmlns:a16="http://schemas.microsoft.com/office/drawing/2014/main" id="{6F4894B8-2B07-AC18-67DC-B4E5A33B756F}"/>
+              </a:ext>
+            </a:extLst>
+          </p:cNvPr>
+          <p:cNvPicPr>
+            <a:picLocks noChangeAspect="1"/>
+          </p:cNvPicPr>
+          <p:nvPr/>
+        </p:nvPicPr>
+        <p:blipFill>
+          <a:blip r:embed="rId5"/>
+          <a:stretch>
+            <a:fillRect/>
+          </a:stretch>
+        </p:blipFill>
+        <p:spPr>
+          <a:xfrm>
+            <a:off x="4256577" y="351676"/>
+            <a:ext cx="3606850" cy="3330861"/>
+          </a:xfrm>
+          <a:prstGeom prst="rect">
+            <a:avLst/>
+          </a:prstGeom>
+        </p:spPr>
+      </p:pic>
+      <p:pic>
+        <p:nvPicPr>
+          <p:cNvPr id="6" name="Image 28" descr="preencoded.png">
+            <a:extLst>
+              <a:ext uri="{FF2B5EF4-FFF2-40B4-BE49-F238E27FC236}">
+                <a16:creationId xmlns:a16="http://schemas.microsoft.com/office/drawing/2014/main" id="{AA7BE37E-E349-328E-CDDC-CCC03EF90412}"/>
+              </a:ext>
+            </a:extLst>
+          </p:cNvPr>
+          <p:cNvPicPr>
+            <a:picLocks noChangeAspect="1"/>
+          </p:cNvPicPr>
+          <p:nvPr/>
+        </p:nvPicPr>
+        <p:blipFill>
+          <a:blip r:embed="rId5"/>
+          <a:stretch>
+            <a:fillRect/>
+          </a:stretch>
+        </p:blipFill>
+        <p:spPr>
+          <a:xfrm>
+            <a:off x="2471948" y="3713101"/>
+            <a:ext cx="3299810" cy="3047315"/>
+          </a:xfrm>
+          <a:prstGeom prst="rect">
+            <a:avLst/>
+          </a:prstGeom>
+        </p:spPr>
+      </p:pic>
+      <p:pic>
+        <p:nvPicPr>
+          <p:cNvPr id="12" name="Picture 11">
+            <a:extLst>
+              <a:ext uri="{FF2B5EF4-FFF2-40B4-BE49-F238E27FC236}">
+                <a16:creationId xmlns:a16="http://schemas.microsoft.com/office/drawing/2014/main" id="{236AE8A9-3BCE-061D-687A-54F652EA1E39}"/>
+              </a:ext>
+            </a:extLst>
+          </p:cNvPr>
+          <p:cNvPicPr>
+            <a:picLocks noChangeAspect="1"/>
+          </p:cNvPicPr>
+          <p:nvPr/>
+        </p:nvPicPr>
+        <p:blipFill>
+          <a:blip r:embed="rId9"/>
+          <a:stretch>
+            <a:fillRect/>
+          </a:stretch>
+        </p:blipFill>
+        <p:spPr>
+          <a:xfrm>
+            <a:off x="2579041" y="3843242"/>
+            <a:ext cx="3083244" cy="2483662"/>
+          </a:xfrm>
+          <a:prstGeom prst="rect">
+            <a:avLst/>
+          </a:prstGeom>
+        </p:spPr>
+      </p:pic>
+      <p:sp>
+        <p:nvSpPr>
+          <p:cNvPr id="13" name="Text 21">
+            <a:extLst>
+              <a:ext uri="{FF2B5EF4-FFF2-40B4-BE49-F238E27FC236}">
+                <a16:creationId xmlns:a16="http://schemas.microsoft.com/office/drawing/2014/main" id="{A32CAA90-7465-CA46-3A4B-F39975B71FDE}"/>
+              </a:ext>
+            </a:extLst>
+          </p:cNvPr>
+          <p:cNvSpPr/>
+          <p:nvPr/>
+        </p:nvSpPr>
+        <p:spPr>
+          <a:xfrm>
+            <a:off x="2542993" y="6326904"/>
+            <a:ext cx="3119292" cy="343845"/>
+          </a:xfrm>
+          <a:prstGeom prst="rect">
+            <a:avLst/>
+          </a:prstGeom>
+          <a:noFill/>
+          <a:ln/>
+        </p:spPr>
+        <p:txBody>
+          <a:bodyPr vert="horz" wrap="square" lIns="0" tIns="0" rIns="0" bIns="0" rtlCol="0" anchor="t"/>
+          <a:lstStyle/>
+          <a:p>
+            <a:pPr marL="0" indent="0" algn="ctr">
+              <a:lnSpc>
+                <a:spcPts val="1500"/>
+              </a:lnSpc>
+              <a:buNone/>
+            </a:pPr>
+            <a:r>
+              <a:rPr lang="en-US" sz="1050" dirty="0">
+                <a:solidFill>
+                  <a:srgbClr val="D1D5DB"/>
+                </a:solidFill>
+                <a:latin typeface="Open Sans" pitchFamily="34" charset="0"/>
+                <a:ea typeface="Open Sans" pitchFamily="34" charset="-122"/>
+                <a:cs typeface="Open Sans" pitchFamily="34" charset="-120"/>
+              </a:rPr>
+              <a:t>Figure: Word2Vec with Neural Network Models</a:t>
+            </a:r>
+            <a:endParaRPr lang="en-US" sz="1050" dirty="0"/>
+          </a:p>
+        </p:txBody>
+      </p:sp>
+      <p:pic>
+        <p:nvPicPr>
+          <p:cNvPr id="17" name="Picture 16" descr="A diagram of a diagram&#10;&#10;AI-generated content may be incorrect.">
+            <a:extLst>
+              <a:ext uri="{FF2B5EF4-FFF2-40B4-BE49-F238E27FC236}">
+                <a16:creationId xmlns:a16="http://schemas.microsoft.com/office/drawing/2014/main" id="{519E690C-6C86-30FF-6249-F2E2ED9401EC}"/>
+              </a:ext>
+            </a:extLst>
+          </p:cNvPr>
+          <p:cNvPicPr>
+            <a:picLocks noChangeAspect="1"/>
+          </p:cNvPicPr>
+          <p:nvPr/>
+        </p:nvPicPr>
+        <p:blipFill>
+          <a:blip r:embed="rId10"/>
+          <a:stretch>
+            <a:fillRect/>
+          </a:stretch>
+        </p:blipFill>
+        <p:spPr>
+          <a:xfrm>
+            <a:off x="8979666" y="708823"/>
+            <a:ext cx="2369127" cy="4730685"/>
+          </a:xfrm>
+          <a:prstGeom prst="rect">
+            <a:avLst/>
+          </a:prstGeom>
+        </p:spPr>
+      </p:pic>
+      <p:pic>
+        <p:nvPicPr>
+          <p:cNvPr id="20" name="Image 28" descr="preencoded.png">
+            <a:extLst>
+              <a:ext uri="{FF2B5EF4-FFF2-40B4-BE49-F238E27FC236}">
+                <a16:creationId xmlns:a16="http://schemas.microsoft.com/office/drawing/2014/main" id="{188C3EED-3DBF-66DC-B546-99CE1CD725FD}"/>
+              </a:ext>
+            </a:extLst>
+          </p:cNvPr>
+          <p:cNvPicPr>
+            <a:picLocks noChangeAspect="1"/>
+          </p:cNvPicPr>
+          <p:nvPr/>
+        </p:nvPicPr>
+        <p:blipFill>
+          <a:blip r:embed="rId5"/>
+          <a:stretch>
+            <a:fillRect/>
+          </a:stretch>
+        </p:blipFill>
+        <p:spPr>
+          <a:xfrm>
+            <a:off x="8514325" y="623759"/>
+            <a:ext cx="3299810" cy="5355009"/>
+          </a:xfrm>
+          <a:prstGeom prst="rect">
+            <a:avLst/>
+          </a:prstGeom>
+        </p:spPr>
+      </p:pic>
+      <p:sp>
+        <p:nvSpPr>
+          <p:cNvPr id="21" name="Text 21">
+            <a:extLst>
+              <a:ext uri="{FF2B5EF4-FFF2-40B4-BE49-F238E27FC236}">
+                <a16:creationId xmlns:a16="http://schemas.microsoft.com/office/drawing/2014/main" id="{7B06FC1C-2ABE-213F-3959-A52101BB66D2}"/>
+              </a:ext>
+            </a:extLst>
+          </p:cNvPr>
+          <p:cNvSpPr/>
+          <p:nvPr/>
+        </p:nvSpPr>
+        <p:spPr>
+          <a:xfrm>
+            <a:off x="8604583" y="5561011"/>
+            <a:ext cx="3119292" cy="343845"/>
+          </a:xfrm>
+          <a:prstGeom prst="rect">
+            <a:avLst/>
+          </a:prstGeom>
+          <a:noFill/>
+          <a:ln/>
+        </p:spPr>
+        <p:txBody>
+          <a:bodyPr vert="horz" wrap="square" lIns="0" tIns="0" rIns="0" bIns="0" rtlCol="0" anchor="t"/>
+          <a:lstStyle/>
+          <a:p>
+            <a:pPr marL="0" indent="0" algn="ctr">
+              <a:lnSpc>
+                <a:spcPts val="1500"/>
+              </a:lnSpc>
+              <a:buNone/>
+            </a:pPr>
+            <a:r>
+              <a:rPr lang="en-US" sz="1050" dirty="0">
+                <a:solidFill>
+                  <a:srgbClr val="D1D5DB"/>
+                </a:solidFill>
+                <a:latin typeface="Open Sans" pitchFamily="34" charset="0"/>
+                <a:ea typeface="Open Sans" pitchFamily="34" charset="-122"/>
+                <a:cs typeface="Open Sans" pitchFamily="34" charset="-120"/>
+              </a:rPr>
+              <a:t>Figure: BERT with an MLP Classification Layer Models</a:t>
+            </a:r>
+            <a:endParaRPr lang="en-US" sz="1050" dirty="0"/>
+          </a:p>
+        </p:txBody>
+      </p:sp>
+    </p:spTree>
+    <p:extLst>
+      <p:ext uri="{BB962C8B-B14F-4D97-AF65-F5344CB8AC3E}">
+        <p14:creationId xmlns:p14="http://schemas.microsoft.com/office/powerpoint/2010/main" val="2726261902"/>
+      </p:ext>
+    </p:extLst>
+  </p:cSld>
+  <p:clrMapOvr>
+    <a:masterClrMapping/>
+  </p:clrMapOvr>
+</p:sld>
+</file>
+
 <file path=ppt/slides/slide2.xml><?xml version="1.0" encoding="utf-8"?>
 <p:sld xmlns:a="http://schemas.openxmlformats.org/drawingml/2006/main" xmlns:r="http://schemas.openxmlformats.org/officeDocument/2006/relationships" xmlns:p="http://schemas.openxmlformats.org/presentationml/2006/main">
   <p:cSld name="Slide 2">
@@ -10294,7 +11004,7 @@
         </p:blipFill>
         <p:spPr>
           <a:xfrm>
-            <a:off x="0" y="0"/>
+            <a:off x="0" y="-22139"/>
             <a:ext cx="12192000" cy="6858000"/>
           </a:xfrm>
           <a:prstGeom prst="rect">
@@ -10366,7 +11076,7 @@
         </p:blipFill>
         <p:spPr>
           <a:xfrm>
-            <a:off x="438150" y="1209675"/>
+            <a:off x="1327160" y="1552575"/>
             <a:ext cx="200025" cy="228600"/>
           </a:xfrm>
           <a:prstGeom prst="rect">
@@ -10390,7 +11100,7 @@
         </p:blipFill>
         <p:spPr>
           <a:xfrm>
-            <a:off x="438150" y="1628775"/>
+            <a:off x="1327160" y="1971675"/>
             <a:ext cx="3606850" cy="1485900"/>
           </a:xfrm>
           <a:prstGeom prst="rect">
@@ -10414,7 +11124,7 @@
         </p:blipFill>
         <p:spPr>
           <a:xfrm>
-            <a:off x="590550" y="1819275"/>
+            <a:off x="1479560" y="2162175"/>
             <a:ext cx="171450" cy="190500"/>
           </a:xfrm>
           <a:prstGeom prst="rect">
@@ -10438,7 +11148,7 @@
         </p:blipFill>
         <p:spPr>
           <a:xfrm>
-            <a:off x="666750" y="2162175"/>
+            <a:off x="1555760" y="2505075"/>
             <a:ext cx="152400" cy="152400"/>
           </a:xfrm>
           <a:prstGeom prst="rect">
@@ -10462,7 +11172,7 @@
         </p:blipFill>
         <p:spPr>
           <a:xfrm>
-            <a:off x="666750" y="2466975"/>
+            <a:off x="1555760" y="2809875"/>
             <a:ext cx="152400" cy="152400"/>
           </a:xfrm>
           <a:prstGeom prst="rect">
@@ -10486,7 +11196,7 @@
         </p:blipFill>
         <p:spPr>
           <a:xfrm>
-            <a:off x="666750" y="2771775"/>
+            <a:off x="1555760" y="3114675"/>
             <a:ext cx="152400" cy="152400"/>
           </a:xfrm>
           <a:prstGeom prst="rect">
@@ -10510,7 +11220,7 @@
         </p:blipFill>
         <p:spPr>
           <a:xfrm>
-            <a:off x="438150" y="3267075"/>
+            <a:off x="1327160" y="3609975"/>
             <a:ext cx="3606850" cy="1485900"/>
           </a:xfrm>
           <a:prstGeom prst="rect">
@@ -10534,7 +11244,7 @@
         </p:blipFill>
         <p:spPr>
           <a:xfrm>
-            <a:off x="590550" y="3457575"/>
+            <a:off x="1479560" y="3800475"/>
             <a:ext cx="190500" cy="190500"/>
           </a:xfrm>
           <a:prstGeom prst="rect">
@@ -10558,7 +11268,7 @@
         </p:blipFill>
         <p:spPr>
           <a:xfrm>
-            <a:off x="666750" y="3800475"/>
+            <a:off x="1555760" y="4143375"/>
             <a:ext cx="152400" cy="152400"/>
           </a:xfrm>
           <a:prstGeom prst="rect">
@@ -10582,7 +11292,7 @@
         </p:blipFill>
         <p:spPr>
           <a:xfrm>
-            <a:off x="666750" y="4105275"/>
+            <a:off x="1555760" y="4448175"/>
             <a:ext cx="152400" cy="152400"/>
           </a:xfrm>
           <a:prstGeom prst="rect">
@@ -10606,7 +11316,7 @@
         </p:blipFill>
         <p:spPr>
           <a:xfrm>
-            <a:off x="666750" y="4410075"/>
+            <a:off x="1555760" y="4752975"/>
             <a:ext cx="152400" cy="152400"/>
           </a:xfrm>
           <a:prstGeom prst="rect">
@@ -10630,7 +11340,7 @@
         </p:blipFill>
         <p:spPr>
           <a:xfrm>
-            <a:off x="4273600" y="1209675"/>
+            <a:off x="7394659" y="1539961"/>
             <a:ext cx="228600" cy="228600"/>
           </a:xfrm>
           <a:prstGeom prst="rect">
@@ -10654,7 +11364,7 @@
         </p:blipFill>
         <p:spPr>
           <a:xfrm>
-            <a:off x="4273600" y="1628775"/>
+            <a:off x="7394659" y="1959061"/>
             <a:ext cx="3606850" cy="1143000"/>
           </a:xfrm>
           <a:prstGeom prst="rect">
@@ -10678,7 +11388,7 @@
         </p:blipFill>
         <p:spPr>
           <a:xfrm>
-            <a:off x="4426000" y="1819275"/>
+            <a:off x="7547059" y="2149561"/>
             <a:ext cx="190500" cy="190500"/>
           </a:xfrm>
           <a:prstGeom prst="rect">
@@ -10702,7 +11412,7 @@
         </p:blipFill>
         <p:spPr>
           <a:xfrm>
-            <a:off x="4502200" y="2162175"/>
+            <a:off x="7623259" y="2492461"/>
             <a:ext cx="76200" cy="152400"/>
           </a:xfrm>
           <a:prstGeom prst="rect">
@@ -10726,7 +11436,7 @@
         </p:blipFill>
         <p:spPr>
           <a:xfrm>
-            <a:off x="4502200" y="2428875"/>
+            <a:off x="7623259" y="2759161"/>
             <a:ext cx="76200" cy="152400"/>
           </a:xfrm>
           <a:prstGeom prst="rect">
@@ -10750,7 +11460,7 @@
         </p:blipFill>
         <p:spPr>
           <a:xfrm>
-            <a:off x="4273600" y="2924175"/>
+            <a:off x="7394659" y="3254461"/>
             <a:ext cx="3606850" cy="1143000"/>
           </a:xfrm>
           <a:prstGeom prst="rect">
@@ -10774,7 +11484,7 @@
         </p:blipFill>
         <p:spPr>
           <a:xfrm>
-            <a:off x="4426000" y="3114675"/>
+            <a:off x="7547059" y="3444961"/>
             <a:ext cx="171450" cy="190500"/>
           </a:xfrm>
           <a:prstGeom prst="rect">
@@ -10798,7 +11508,7 @@
         </p:blipFill>
         <p:spPr>
           <a:xfrm>
-            <a:off x="4502200" y="3457575"/>
+            <a:off x="7623259" y="3787861"/>
             <a:ext cx="76200" cy="152400"/>
           </a:xfrm>
           <a:prstGeom prst="rect">
@@ -10822,7 +11532,7 @@
         </p:blipFill>
         <p:spPr>
           <a:xfrm>
-            <a:off x="4502200" y="3724275"/>
+            <a:off x="7623259" y="4054561"/>
             <a:ext cx="76200" cy="152400"/>
           </a:xfrm>
           <a:prstGeom prst="rect">
@@ -10846,7 +11556,7 @@
         </p:blipFill>
         <p:spPr>
           <a:xfrm>
-            <a:off x="4273600" y="4219575"/>
+            <a:off x="7394659" y="4549861"/>
             <a:ext cx="3606850" cy="1371600"/>
           </a:xfrm>
           <a:prstGeom prst="rect">
@@ -10870,7 +11580,7 @@
         </p:blipFill>
         <p:spPr>
           <a:xfrm>
-            <a:off x="4426000" y="4410075"/>
+            <a:off x="7547059" y="4740361"/>
             <a:ext cx="190500" cy="190500"/>
           </a:xfrm>
           <a:prstGeom prst="rect">
@@ -10894,7 +11604,7 @@
         </p:blipFill>
         <p:spPr>
           <a:xfrm>
-            <a:off x="4502200" y="4752975"/>
+            <a:off x="7623259" y="5083261"/>
             <a:ext cx="76200" cy="152400"/>
           </a:xfrm>
           <a:prstGeom prst="rect">
@@ -10918,7 +11628,7 @@
         </p:blipFill>
         <p:spPr>
           <a:xfrm>
-            <a:off x="4502200" y="5019675"/>
+            <a:off x="7623259" y="5349961"/>
             <a:ext cx="76200" cy="152400"/>
           </a:xfrm>
           <a:prstGeom prst="rect">
@@ -10928,7 +11638,7 @@
       </p:pic>
       <p:pic>
         <p:nvPicPr>
-          <p:cNvPr id="29" name="Image 27" descr="preencoded.png"/>
+          <p:cNvPr id="32" name="Image 30" descr="preencoded.png"/>
           <p:cNvPicPr>
             <a:picLocks noChangeAspect="1"/>
           </p:cNvPicPr>
@@ -10936,78 +11646,6 @@
         </p:nvPicPr>
         <p:blipFill>
           <a:blip r:embed="rId19"/>
-          <a:stretch>
-            <a:fillRect/>
-          </a:stretch>
-        </p:blipFill>
-        <p:spPr>
-          <a:xfrm>
-            <a:off x="8109049" y="1209675"/>
-            <a:ext cx="257175" cy="228600"/>
-          </a:xfrm>
-          <a:prstGeom prst="rect">
-            <a:avLst/>
-          </a:prstGeom>
-        </p:spPr>
-      </p:pic>
-      <p:pic>
-        <p:nvPicPr>
-          <p:cNvPr id="30" name="Image 28" descr="preencoded.png"/>
-          <p:cNvPicPr>
-            <a:picLocks noChangeAspect="1"/>
-          </p:cNvPicPr>
-          <p:nvPr/>
-        </p:nvPicPr>
-        <p:blipFill>
-          <a:blip r:embed="rId20"/>
-          <a:stretch>
-            <a:fillRect/>
-          </a:stretch>
-        </p:blipFill>
-        <p:spPr>
-          <a:xfrm>
-            <a:off x="8109049" y="1628775"/>
-            <a:ext cx="3606850" cy="4762500"/>
-          </a:xfrm>
-          <a:prstGeom prst="rect">
-            <a:avLst/>
-          </a:prstGeom>
-        </p:spPr>
-      </p:pic>
-      <p:pic>
-        <p:nvPicPr>
-          <p:cNvPr id="31" name="Image 29" descr="preencoded.png"/>
-          <p:cNvPicPr>
-            <a:picLocks noChangeAspect="1"/>
-          </p:cNvPicPr>
-          <p:nvPr/>
-        </p:nvPicPr>
-        <p:blipFill>
-          <a:blip r:embed="rId21"/>
-          <a:stretch>
-            <a:fillRect/>
-          </a:stretch>
-        </p:blipFill>
-        <p:spPr>
-          <a:xfrm>
-            <a:off x="8204299" y="1743075"/>
-            <a:ext cx="3378250" cy="2710160"/>
-          </a:xfrm>
-          <a:prstGeom prst="rect">
-            <a:avLst/>
-          </a:prstGeom>
-        </p:spPr>
-      </p:pic>
-      <p:pic>
-        <p:nvPicPr>
-          <p:cNvPr id="32" name="Image 30" descr="preencoded.png"/>
-          <p:cNvPicPr>
-            <a:picLocks noChangeAspect="1"/>
-          </p:cNvPicPr>
-          <p:nvPr/>
-        </p:nvPicPr>
-        <p:blipFill>
-          <a:blip r:embed="rId22"/>
           <a:stretch>
             <a:fillRect/>
           </a:stretch>
@@ -11031,7 +11669,7 @@
           <p:nvPr/>
         </p:nvPicPr>
         <p:blipFill>
-          <a:blip r:embed="rId22"/>
+          <a:blip r:embed="rId19"/>
           <a:stretch>
             <a:fillRect/>
           </a:stretch>
@@ -11096,7 +11734,7 @@
         </p:nvSpPr>
         <p:spPr>
           <a:xfrm>
-            <a:off x="752475" y="1171575"/>
+            <a:off x="1631960" y="1502891"/>
             <a:ext cx="4328220" cy="304800"/>
           </a:xfrm>
           <a:prstGeom prst="rect">
@@ -11138,7 +11776,7 @@
         </p:nvSpPr>
         <p:spPr>
           <a:xfrm>
-            <a:off x="838200" y="1781175"/>
+            <a:off x="1784360" y="2090738"/>
             <a:ext cx="3962460" cy="266700"/>
           </a:xfrm>
           <a:prstGeom prst="rect">
@@ -11180,7 +11818,7 @@
         </p:nvSpPr>
         <p:spPr>
           <a:xfrm>
-            <a:off x="895350" y="2124075"/>
+            <a:off x="1784360" y="2466975"/>
             <a:ext cx="3086100" cy="228600"/>
           </a:xfrm>
           <a:prstGeom prst="rect">
@@ -11222,7 +11860,7 @@
         </p:nvSpPr>
         <p:spPr>
           <a:xfrm>
-            <a:off x="895350" y="2428875"/>
+            <a:off x="1784360" y="2771775"/>
             <a:ext cx="3051810" cy="228600"/>
           </a:xfrm>
           <a:prstGeom prst="rect">
@@ -11264,7 +11902,7 @@
         </p:nvSpPr>
         <p:spPr>
           <a:xfrm>
-            <a:off x="895350" y="2733675"/>
+            <a:off x="1784360" y="3076575"/>
             <a:ext cx="2537460" cy="228600"/>
           </a:xfrm>
           <a:prstGeom prst="rect">
@@ -11306,7 +11944,7 @@
         </p:nvSpPr>
         <p:spPr>
           <a:xfrm>
-            <a:off x="857250" y="3419475"/>
+            <a:off x="1746260" y="3762375"/>
             <a:ext cx="3302050" cy="266700"/>
           </a:xfrm>
           <a:prstGeom prst="rect">
@@ -11348,7 +11986,7 @@
         </p:nvSpPr>
         <p:spPr>
           <a:xfrm>
-            <a:off x="895350" y="3762375"/>
+            <a:off x="1784360" y="4105275"/>
             <a:ext cx="2754630" cy="228600"/>
           </a:xfrm>
           <a:prstGeom prst="rect">
@@ -11390,7 +12028,7 @@
         </p:nvSpPr>
         <p:spPr>
           <a:xfrm>
-            <a:off x="895350" y="4067175"/>
+            <a:off x="1784360" y="4410075"/>
             <a:ext cx="1623060" cy="228600"/>
           </a:xfrm>
           <a:prstGeom prst="rect">
@@ -11432,7 +12070,7 @@
         </p:nvSpPr>
         <p:spPr>
           <a:xfrm>
-            <a:off x="895350" y="4371975"/>
+            <a:off x="1784360" y="4714875"/>
             <a:ext cx="2446020" cy="228600"/>
           </a:xfrm>
           <a:prstGeom prst="rect">
@@ -11474,7 +12112,7 @@
         </p:nvSpPr>
         <p:spPr>
           <a:xfrm>
-            <a:off x="4616500" y="1171575"/>
+            <a:off x="7718509" y="1501861"/>
             <a:ext cx="4328220" cy="304800"/>
           </a:xfrm>
           <a:prstGeom prst="rect">
@@ -11516,7 +12154,7 @@
         </p:nvSpPr>
         <p:spPr>
           <a:xfrm>
-            <a:off x="4692700" y="1781175"/>
+            <a:off x="7813759" y="2119442"/>
             <a:ext cx="3962460" cy="266700"/>
           </a:xfrm>
           <a:prstGeom prst="rect">
@@ -11558,7 +12196,7 @@
         </p:nvSpPr>
         <p:spPr>
           <a:xfrm>
-            <a:off x="4654600" y="2124075"/>
+            <a:off x="7775659" y="2454361"/>
             <a:ext cx="1337310" cy="228600"/>
           </a:xfrm>
           <a:prstGeom prst="rect">
@@ -11600,7 +12238,7 @@
         </p:nvSpPr>
         <p:spPr>
           <a:xfrm>
-            <a:off x="4654600" y="2390775"/>
+            <a:off x="7775659" y="2721061"/>
             <a:ext cx="2983230" cy="228600"/>
           </a:xfrm>
           <a:prstGeom prst="rect">
@@ -11642,7 +12280,7 @@
         </p:nvSpPr>
         <p:spPr>
           <a:xfrm>
-            <a:off x="4673650" y="3076575"/>
+            <a:off x="7794709" y="3406861"/>
             <a:ext cx="3302050" cy="266700"/>
           </a:xfrm>
           <a:prstGeom prst="rect">
@@ -11684,7 +12322,7 @@
         </p:nvSpPr>
         <p:spPr>
           <a:xfrm>
-            <a:off x="4654600" y="3419475"/>
+            <a:off x="7775659" y="3749761"/>
             <a:ext cx="2320290" cy="228600"/>
           </a:xfrm>
           <a:prstGeom prst="rect">
@@ -11726,7 +12364,7 @@
         </p:nvSpPr>
         <p:spPr>
           <a:xfrm>
-            <a:off x="4654600" y="3686175"/>
+            <a:off x="7775659" y="4016461"/>
             <a:ext cx="2903220" cy="228600"/>
           </a:xfrm>
           <a:prstGeom prst="rect">
@@ -11768,7 +12406,7 @@
         </p:nvSpPr>
         <p:spPr>
           <a:xfrm>
-            <a:off x="4692700" y="4371975"/>
+            <a:off x="7813759" y="4702261"/>
             <a:ext cx="3302050" cy="266700"/>
           </a:xfrm>
           <a:prstGeom prst="rect">
@@ -11810,7 +12448,7 @@
         </p:nvSpPr>
         <p:spPr>
           <a:xfrm>
-            <a:off x="4654600" y="4714875"/>
+            <a:off x="7775659" y="5045161"/>
             <a:ext cx="2800350" cy="228600"/>
           </a:xfrm>
           <a:prstGeom prst="rect">
@@ -11852,7 +12490,7 @@
         </p:nvSpPr>
         <p:spPr>
           <a:xfrm>
-            <a:off x="4654600" y="4981575"/>
+            <a:off x="7775659" y="5311861"/>
             <a:ext cx="3073450" cy="457200"/>
           </a:xfrm>
           <a:prstGeom prst="rect">
@@ -11883,90 +12521,6 @@
               <a:t>Enhanced performance over Random Forests</a:t>
             </a:r>
             <a:endParaRPr lang="en-US" sz="1200" dirty="0"/>
-          </a:p>
-        </p:txBody>
-      </p:sp>
-      <p:sp>
-        <p:nvSpPr>
-          <p:cNvPr id="54" name="Text 20"/>
-          <p:cNvSpPr/>
-          <p:nvPr/>
-        </p:nvSpPr>
-        <p:spPr>
-          <a:xfrm>
-            <a:off x="8480524" y="1171575"/>
-            <a:ext cx="3606850" cy="304800"/>
-          </a:xfrm>
-          <a:prstGeom prst="rect">
-            <a:avLst/>
-          </a:prstGeom>
-          <a:noFill/>
-          <a:ln/>
-        </p:spPr>
-        <p:txBody>
-          <a:bodyPr vert="horz" wrap="square" lIns="0" tIns="0" rIns="0" bIns="0" rtlCol="0" anchor="t"/>
-          <a:lstStyle/>
-          <a:p>
-            <a:pPr marL="0" indent="0">
-              <a:lnSpc>
-                <a:spcPts val="2400"/>
-              </a:lnSpc>
-              <a:buNone/>
-            </a:pPr>
-            <a:r>
-              <a:rPr lang="en-US" sz="1800" dirty="0">
-                <a:solidFill>
-                  <a:srgbClr val="FFFFFF"/>
-                </a:solidFill>
-                <a:latin typeface="Montserrat" pitchFamily="34" charset="0"/>
-                <a:ea typeface="Montserrat" pitchFamily="34" charset="-122"/>
-                <a:cs typeface="Montserrat" pitchFamily="34" charset="-120"/>
-              </a:rPr>
-              <a:t>Workflow</a:t>
-            </a:r>
-            <a:endParaRPr lang="en-US" sz="1800" dirty="0"/>
-          </a:p>
-        </p:txBody>
-      </p:sp>
-      <p:sp>
-        <p:nvSpPr>
-          <p:cNvPr id="55" name="Text 21"/>
-          <p:cNvSpPr/>
-          <p:nvPr/>
-        </p:nvSpPr>
-        <p:spPr>
-          <a:xfrm>
-            <a:off x="8223349" y="5231755"/>
-            <a:ext cx="3378250" cy="381000"/>
-          </a:xfrm>
-          <a:prstGeom prst="rect">
-            <a:avLst/>
-          </a:prstGeom>
-          <a:noFill/>
-          <a:ln/>
-        </p:spPr>
-        <p:txBody>
-          <a:bodyPr vert="horz" wrap="square" lIns="0" tIns="0" rIns="0" bIns="0" rtlCol="0" anchor="t"/>
-          <a:lstStyle/>
-          <a:p>
-            <a:pPr marL="0" indent="0" algn="ctr">
-              <a:lnSpc>
-                <a:spcPts val="1500"/>
-              </a:lnSpc>
-              <a:buNone/>
-            </a:pPr>
-            <a:r>
-              <a:rPr lang="en-US" sz="1050" dirty="0">
-                <a:solidFill>
-                  <a:srgbClr val="D1D5DB"/>
-                </a:solidFill>
-                <a:latin typeface="Open Sans" pitchFamily="34" charset="0"/>
-                <a:ea typeface="Open Sans" pitchFamily="34" charset="-122"/>
-                <a:cs typeface="Open Sans" pitchFamily="34" charset="-120"/>
-              </a:rPr>
-              <a:t>Figure: TF-IDF Vectorizer Workflow for Classical Models</a:t>
-            </a:r>
-            <a:endParaRPr lang="en-US" sz="1050" dirty="0"/>
           </a:p>
         </p:txBody>
       </p:sp>
@@ -12127,36 +12681,6 @@
           </a:prstGeom>
         </p:spPr>
       </p:pic>
-      <p:pic>
-        <p:nvPicPr>
-          <p:cNvPr id="6" name="Image 29" descr="preencoded.png">
-            <a:extLst>
-              <a:ext uri="{FF2B5EF4-FFF2-40B4-BE49-F238E27FC236}">
-                <a16:creationId xmlns:a16="http://schemas.microsoft.com/office/drawing/2014/main" id="{49AA14AE-F949-2EBF-FDB5-FCF495491A24}"/>
-              </a:ext>
-            </a:extLst>
-          </p:cNvPr>
-          <p:cNvPicPr>
-            <a:picLocks noChangeAspect="1"/>
-          </p:cNvPicPr>
-          <p:nvPr/>
-        </p:nvPicPr>
-        <p:blipFill>
-          <a:blip r:embed="rId5"/>
-          <a:stretch>
-            <a:fillRect/>
-          </a:stretch>
-        </p:blipFill>
-        <p:spPr>
-          <a:xfrm>
-            <a:off x="6772349" y="1773585"/>
-            <a:ext cx="3378250" cy="2710160"/>
-          </a:xfrm>
-          <a:prstGeom prst="rect">
-            <a:avLst/>
-          </a:prstGeom>
-        </p:spPr>
-      </p:pic>
       <p:sp>
         <p:nvSpPr>
           <p:cNvPr id="8" name="Text 21">
@@ -12220,7 +12744,7 @@
           <p:nvPr/>
         </p:nvPicPr>
         <p:blipFill>
-          <a:blip r:embed="rId6"/>
+          <a:blip r:embed="rId5"/>
           <a:stretch>
             <a:fillRect/>
           </a:stretch>
@@ -12328,7 +12852,7 @@
           <p:nvPr/>
         </p:nvPicPr>
         <p:blipFill>
-          <a:blip r:embed="rId7"/>
+          <a:blip r:embed="rId6"/>
           <a:stretch>
             <a:fillRect/>
           </a:stretch>
@@ -12406,7 +12930,7 @@
           <p:nvPr/>
         </p:nvPicPr>
         <p:blipFill>
-          <a:blip r:embed="rId8"/>
+          <a:blip r:embed="rId7"/>
           <a:stretch>
             <a:fillRect/>
           </a:stretch>
@@ -12415,6 +12939,36 @@
           <a:xfrm>
             <a:off x="2041401" y="1776295"/>
             <a:ext cx="3378250" cy="2707450"/>
+          </a:xfrm>
+          <a:prstGeom prst="rect">
+            <a:avLst/>
+          </a:prstGeom>
+        </p:spPr>
+      </p:pic>
+      <p:pic>
+        <p:nvPicPr>
+          <p:cNvPr id="24" name="Picture 23" descr="A diagram of a model&#10;&#10;AI-generated content may be incorrect.">
+            <a:extLst>
+              <a:ext uri="{FF2B5EF4-FFF2-40B4-BE49-F238E27FC236}">
+                <a16:creationId xmlns:a16="http://schemas.microsoft.com/office/drawing/2014/main" id="{BF8F7D5E-3CCB-7F2E-5C73-18C62D4FD2EB}"/>
+              </a:ext>
+            </a:extLst>
+          </p:cNvPr>
+          <p:cNvPicPr>
+            <a:picLocks noChangeAspect="1"/>
+          </p:cNvPicPr>
+          <p:nvPr/>
+        </p:nvPicPr>
+        <p:blipFill>
+          <a:blip r:embed="rId8"/>
+          <a:stretch>
+            <a:fillRect/>
+          </a:stretch>
+        </p:blipFill>
+        <p:spPr>
+          <a:xfrm>
+            <a:off x="6775841" y="1776295"/>
+            <a:ext cx="3393808" cy="2707450"/>
           </a:xfrm>
           <a:prstGeom prst="rect">
             <a:avLst/>

</xml_diff>